<commit_message>
Update title slide with team member names and roll numbers
</commit_message>
<xml_diff>
--- a/UniVerify_Final_Presentation.pptx
+++ b/UniVerify_Final_Presentation.pptx
@@ -4265,7 +4265,7 @@
         </p:nvSpPr>
         <p:spPr>
           <a:xfrm>
-            <a:off x="822960" y="5532120"/>
+            <a:off x="822960" y="5440680"/>
             <a:ext cx="3840480" cy="25400"/>
           </a:xfrm>
           <a:prstGeom prst="rect">
@@ -4309,8 +4309,8 @@
         </p:nvSpPr>
         <p:spPr>
           <a:xfrm>
-            <a:off x="822960" y="5669280"/>
-            <a:ext cx="10515600" cy="822960"/>
+            <a:off x="822960" y="5577840"/>
+            <a:ext cx="10515600" cy="1097280"/>
           </a:xfrm>
           <a:prstGeom prst="rect">
             <a:avLst/>
@@ -4323,6 +4323,22 @@
           </a:bodyPr>
           <a:lstStyle/>
           <a:p>
+            <a:pPr algn="l">
+              <a:spcAft>
+                <a:spcPts val="200"/>
+              </a:spcAft>
+            </a:pPr>
+            <a:r>
+              <a:rPr sz="1300" b="1" i="0">
+                <a:solidFill>
+                  <a:srgbClr val="58A6FF"/>
+                </a:solidFill>
+                <a:latin typeface="Segoe UI"/>
+              </a:rPr>
+              <a:t>Presented by:</a:t>
+            </a:r>
+          </a:p>
+          <a:p>
             <a:pPr algn="l"/>
             <a:r>
               <a:rPr sz="1400" b="1" i="0">
@@ -4331,17 +4347,29 @@
                 </a:solidFill>
                 <a:latin typeface="Segoe UI"/>
               </a:rPr>
-              <a:t>Presented by:  Shaik M.</a:t>
+              <a:t>Shaik Abdulla M  (231061101493)  •  CSE</a:t>
             </a:r>
           </a:p>
           <a:p>
             <a:pPr algn="l">
-              <a:spcBef>
-                <a:spcPts val="200"/>
-              </a:spcBef>
+              <a:spcAft>
+                <a:spcPts val="300"/>
+              </a:spcAft>
             </a:pPr>
             <a:r>
-              <a:rPr sz="1200" b="0" i="0">
+              <a:rPr sz="1400" b="1" i="0">
+                <a:solidFill>
+                  <a:srgbClr val="F0F6FC"/>
+                </a:solidFill>
+                <a:latin typeface="Segoe UI"/>
+              </a:rPr>
+              <a:t>Narendra Reddy  (231061101489)  •  CSE</a:t>
+            </a:r>
+          </a:p>
+          <a:p>
+            <a:pPr algn="l"/>
+            <a:r>
+              <a:rPr sz="1150" b="0" i="0">
                 <a:solidFill>
                   <a:srgbClr val="8B949E"/>
                 </a:solidFill>

</xml_diff>